<commit_message>
docs(deliverables): PPT 双版本 + 1080p 配音 demo 成片 + 视频制作管线源码
- MedSignal.pptx 重新生成：Demo 4 页新增运营管理后台条目
- 新增 MedSignal-v2.pptx（AI 辅助设计版）
- 新增 MedSignal_demo_1080p.mp4（90 秒配音字幕版，与 4K 版互补）
- video-demo: Remotion 4K 渲染源码 + remake TTS 配音管线脚本
- .gitignore: 忽略 remake 可再生产物（tts/segments/scenes/audio/output）
</commit_message>
<xml_diff>
--- a/docs/MedSignal.pptx
+++ b/docs/MedSignal.pptx
@@ -1567,7 +1567,7 @@
           <a:lstStyle/>
           <a:p>
             <a:r>
-              <a:t>第四个 Demo 是信息连接层。一张票据上传，报销计算七步走；政策匹配按能省多少钱排序，每一条都有政策原文；多智能体协作——当他同时问“脑电异常怎么省钱”，系统会并行调度脑电卫士和政策参谋，一次回答两个问题。最新能力：动态用户管理，现场新增一个用户，不到十秒，对话、健康画像、数字人体档案全站联动；连续对话会话持久化，服务重启后历史可回放。</a:t>
+              <a:t>第四个 Demo 是信息连接层。一张票据上传，报销计算七步走；政策匹配按能省多少钱排序，每一条都有政策原文；多智能体协作——当他同时问“脑电异常怎么省钱”，系统会并行调度脑电卫士和政策参谋，一次回答两个问题。动态用户管理，现场新增一个用户，不到十秒，对话、健康画像、数字人体档案全站联动；连续对话会话持久化，服务重启后历史可回放。另外我们上线了运营管理后台：全用户使用统计与画像分析，支撑精准政策传达、病情告知等服务运营。</a:t>
             </a:r>
           </a:p>
         </p:txBody>
@@ -24142,8 +24142,8 @@
         </p:nvSpPr>
         <p:spPr>
           <a:xfrm>
-            <a:off x="457200" y="5870448"/>
-            <a:ext cx="11274552" cy="621792"/>
+            <a:off x="457200" y="5760720"/>
+            <a:ext cx="11274552" cy="530352"/>
           </a:xfrm>
           <a:prstGeom prst="roundRect">
             <a:avLst>
@@ -24187,6 +24187,63 @@
                 <a:cs typeface="Microsoft YaHei"/>
               </a:rPr>
               <a:t>现场演示 · 动态新增用户 → 对话/健康画像/数字人体档案全站即时联动（&lt; 10 秒）· 会话持久化重启可回放</a:t>
+            </a:r>
+          </a:p>
+        </p:txBody>
+      </p:sp>
+      <p:sp>
+        <p:nvSpPr>
+          <p:cNvPr id="38" name="Rounded Rectangle 37"/>
+          <p:cNvSpPr/>
+          <p:nvPr/>
+        </p:nvSpPr>
+        <p:spPr>
+          <a:xfrm>
+            <a:off x="457200" y="6382512"/>
+            <a:ext cx="11274552" cy="384048"/>
+          </a:xfrm>
+          <a:prstGeom prst="roundRect">
+            <a:avLst>
+              <a:gd name="adj" fmla="val 10000"/>
+            </a:avLst>
+          </a:prstGeom>
+          <a:solidFill>
+            <a:srgbClr val="1A365D"/>
+          </a:solidFill>
+          <a:ln>
+            <a:noFill/>
+          </a:ln>
+          <a:effectLst/>
+        </p:spPr>
+        <p:style>
+          <a:lnRef idx="1">
+            <a:schemeClr val="accent1"/>
+          </a:lnRef>
+          <a:fillRef idx="3">
+            <a:schemeClr val="accent1"/>
+          </a:fillRef>
+          <a:effectRef idx="2">
+            <a:schemeClr val="accent1"/>
+          </a:effectRef>
+          <a:fontRef idx="minor">
+            <a:schemeClr val="lt1"/>
+          </a:fontRef>
+        </p:style>
+        <p:txBody>
+          <a:bodyPr rtlCol="0" anchor="ctr" wrap="square" lIns="63500" rIns="63500" tIns="25400" bIns="25400"/>
+          <a:lstStyle/>
+          <a:p>
+            <a:pPr algn="ctr"/>
+            <a:r>
+              <a:rPr sz="1100" b="1">
+                <a:solidFill>
+                  <a:srgbClr val="FFFFFF"/>
+                </a:solidFill>
+                <a:latin typeface="Microsoft YaHei"/>
+                <a:ea typeface="Microsoft YaHei"/>
+                <a:cs typeface="Microsoft YaHei"/>
+              </a:rPr>
+              <a:t>运营管理后台 · 全用户使用统计 + 画像分析 → 精准政策传达 / 病情告知 / 营销推送</a:t>
             </a:r>
           </a:p>
         </p:txBody>

</xml_diff>